<commit_message>
Fill presenter-notes gaps on slides 5, 7, 8, 9, and 10.
</commit_message>
<xml_diff>
--- a/talks/shipaton-kug-chennai-2026/shipaton-kug-chennai-2026.pptx
+++ b/talks/shipaton-kug-chennai-2026/shipaton-kug-chennai-2026.pptx
@@ -626,6 +626,11 @@
           </a:p>
           <a:p>
             <a:r>
+              <a:t>Tanglish: Banner-ah vechi vidunga. QR invent pannaathinga. DevFest-ku point pannunga.</a:t>
+            </a:r>
+          </a:p>
+          <a:p>
+            <a:r>
               <a:t>https://devfest.gdgchennai.in/ — Saturday 17 October 2026, IITM Research Park.</a:t>
             </a:r>
           </a:p>
@@ -1039,6 +1044,11 @@
               <a:t>Payment validates willingness to pay. It is not product-market fit.</a:t>
             </a:r>
           </a:p>
+          <a:p>
+            <a:r>
+              <a:t>First payment docs: https://razorpay.com/docs/</a:t>
+            </a:r>
+          </a:p>
         </p:txBody>
       </p:sp>
       <p:sp>
@@ -1201,6 +1211,11 @@
           </a:p>
           <a:p>
             <a:r>
+              <a:t>Tanglish: Sheet-la fill pannunga. Review Ready-ku maathunga. Organizers dhaan paathu review pannuvaanga.</a:t>
+            </a:r>
+          </a:p>
+          <a:p>
+            <a:r>
               <a:t>Columns: Product Name, Creator / Team, Product Category, Demo / Product URL, Repository URL, Monetization Model, Payment Integration (Live / Test / Planned), Deployment Status, Review Status (In Progress / Review Ready / Reviewed), Production Ready by Thursday (Yes / No), Notes.</a:t>
             </a:r>
           </a:p>
@@ -1217,6 +1232,11 @@
           <a:p>
             <a:r>
               <a:t>Sheet URL: SHEET_LINK_PLACEHOLDER</a:t>
+            </a:r>
+          </a:p>
+          <a:p>
+            <a:r>
+              <a:t>Event: https://luma.com/mprx0ocg</a:t>
             </a:r>
           </a:p>
         </p:txBody>
@@ -1309,6 +1329,16 @@
               <a:t>Checklist: working production URL or accessible release; core functionality; usable onboarding; no critical blockers; clear monetization; payment flow when applicable; basic analytics or feedback; enough for organizers to test.</a:t>
             </a:r>
           </a:p>
+          <a:p>
+            <a:r>
+              <a:t>Event: https://luma.com/mprx0ocg</a:t>
+            </a:r>
+          </a:p>
+          <a:p>
+            <a:r>
+              <a:t>DevFest: https://devfest.gdgchennai.in/</a:t>
+            </a:r>
+          </a:p>
         </p:txBody>
       </p:sp>
       <p:sp>
@@ -1382,6 +1412,11 @@
           <a:p>
             <a:r>
               <a:t>Prizes also awarded at DevFest: Saturday 17 October 2026, IITM Research Park. https://devfest.gdgchennai.in/</a:t>
+            </a:r>
+          </a:p>
+          <a:p>
+            <a:r>
+              <a:t>Tanglish: Ship pannunga. Review aaganum. Win-na bonus — guarantee illa.</a:t>
             </a:r>
           </a:p>
           <a:p>
@@ -5324,7 +5359,7 @@
       </p:sp>
       <p:pic>
         <p:nvPicPr>
-          <p:cNvPr id="3" name="Picture 2" descr="tmpda7yl5a6.png"/>
+          <p:cNvPr id="3" name="Picture 2" descr="tmp3smv7zdq.png"/>
           <p:cNvPicPr>
             <a:picLocks noChangeAspect="1"/>
           </p:cNvPicPr>

</xml_diff>